<commit_message>
feat(gnn): precision improvement from 7.1% to 9.5% with decoupled balancing and threshold tuning
- Root cause analysis: double-counting (sampler + pos_weight=18.1) and
  broken voltage-bound labeling (64% normal nodes outside bounds)
- Fixed labeling: per-snapshot z-score threshold (|z|>1.8)
- Stronger perturbations: ±25% load deviations
- Decoupled sampler from pos_weight (sampler ON + pw=2.0)
- Inference threshold tuning via 50-step grid search on validation set
- Results: Precision 9.5% (+34%), F1 0.151 (+19%), Accuracy 93.4% (+132%)
- Updated paper §GNN Training Results with new methodology
- Updated PPT slide 13 metrics table and conclusion slide
- Regenerated training loss plot from v5 TensorBoard logs (50 epochs)
- Fixed PPT image aspect ratio distortion (force-stretch → object-fit contain)
- Updated README with full GNN metrics, test counts (139), and v2.1.0
- Updated .gitignore: ignore checkpoints*/ and runs/ directories
</commit_message>
<xml_diff>
--- a/docs/Metro_Grid_Digital_Twin.pptx
+++ b/docs/Metro_Grid_Digital_Twin.pptx
@@ -3516,7 +3516,7 @@
               </a:defRPr>
             </a:pPr>
             <a:r>
-              <a:t>RV College of Engineering® — BMS Institute of Technology</a:t>
+              <a:t>RV College of Engineering® — Bengaluru</a:t>
             </a:r>
           </a:p>
         </p:txBody>
@@ -3796,7 +3796,7 @@
         <p:spPr>
           <a:xfrm>
             <a:off x="457200" y="1645920"/>
-            <a:ext cx="6858000" cy="4572000"/>
+            <a:ext cx="5847841" cy="4572000"/>
           </a:xfrm>
           <a:prstGeom prst="rect">
             <a:avLst/>
@@ -4065,7 +4065,7 @@
               </a:defRPr>
             </a:pPr>
             <a:r>
-              <a:t>RV College of Engineering® — BMS Institute of Technology</a:t>
+              <a:t>RV College of Engineering® — Bengaluru</a:t>
             </a:r>
           </a:p>
         </p:txBody>
@@ -4345,7 +4345,7 @@
         <p:spPr>
           <a:xfrm>
             <a:off x="457200" y="1645920"/>
-            <a:ext cx="6858000" cy="4572000"/>
+            <a:ext cx="6858000" cy="2669453"/>
           </a:xfrm>
           <a:prstGeom prst="rect">
             <a:avLst/>
@@ -4682,7 +4682,7 @@
               </a:defRPr>
             </a:pPr>
             <a:r>
-              <a:t>RV College of Engineering® — BMS Institute of Technology</a:t>
+              <a:t>RV College of Engineering® — Bengaluru</a:t>
             </a:r>
           </a:p>
         </p:txBody>
@@ -4962,7 +4962,7 @@
         <p:spPr>
           <a:xfrm>
             <a:off x="274320" y="1645920"/>
-            <a:ext cx="5669280" cy="4114800"/>
+            <a:ext cx="3967389" cy="4114800"/>
           </a:xfrm>
           <a:prstGeom prst="rect">
             <a:avLst/>
@@ -4986,7 +4986,7 @@
         <p:spPr>
           <a:xfrm>
             <a:off x="6126480" y="1645920"/>
-            <a:ext cx="5669280" cy="4114800"/>
+            <a:ext cx="5669280" cy="2209923"/>
           </a:xfrm>
           <a:prstGeom prst="rect">
             <a:avLst/>
@@ -5136,7 +5136,7 @@
               </a:defRPr>
             </a:pPr>
             <a:r>
-              <a:t>RV College of Engineering® — BMS Institute of Technology</a:t>
+              <a:t>RV College of Engineering® — Bengaluru</a:t>
             </a:r>
           </a:p>
         </p:txBody>
@@ -5416,7 +5416,7 @@
         <p:spPr>
           <a:xfrm>
             <a:off x="274320" y="1645920"/>
-            <a:ext cx="6400800" cy="4572000"/>
+            <a:ext cx="6400800" cy="2495774"/>
           </a:xfrm>
           <a:prstGeom prst="rect">
             <a:avLst/>
@@ -5454,7 +5454,7 @@
               </a:defRPr>
             </a:pPr>
             <a:r>
-              <a:t>RGATv2 Training (28 epochs)</a:t>
+              <a:t>RGATv2 Training (50 epochs)</a:t>
             </a:r>
           </a:p>
         </p:txBody>
@@ -5542,7 +5542,7 @@
               </a:defRPr>
             </a:pPr>
             <a:r>
-              <a:t>1.465</a:t>
+              <a:t>1.262</a:t>
             </a:r>
           </a:p>
         </p:txBody>
@@ -5630,7 +5630,7 @@
               </a:defRPr>
             </a:pPr>
             <a:r>
-              <a:t>40.3%</a:t>
+              <a:t>93.4%</a:t>
             </a:r>
           </a:p>
         </p:txBody>
@@ -5718,7 +5718,7 @@
               </a:defRPr>
             </a:pPr>
             <a:r>
-              <a:t>0.127</a:t>
+              <a:t>0.151</a:t>
             </a:r>
           </a:p>
         </p:txBody>
@@ -5754,7 +5754,7 @@
               </a:defRPr>
             </a:pPr>
             <a:r>
-              <a:t>Recall (Anomalies)</a:t>
+              <a:t>Precision (t=0.60)</a:t>
             </a:r>
           </a:p>
         </p:txBody>
@@ -5806,7 +5806,7 @@
               </a:defRPr>
             </a:pPr>
             <a:r>
-              <a:t>72.6%</a:t>
+              <a:t>9.5%</a:t>
             </a:r>
           </a:p>
         </p:txBody>
@@ -5842,7 +5842,7 @@
               </a:defRPr>
             </a:pPr>
             <a:r>
-              <a:t>Precision</a:t>
+              <a:t>Recall (t=0.60)</a:t>
             </a:r>
           </a:p>
         </p:txBody>
@@ -5894,7 +5894,7 @@
               </a:defRPr>
             </a:pPr>
             <a:r>
-              <a:t>7.1%</a:t>
+              <a:t>35.7%</a:t>
             </a:r>
           </a:p>
         </p:txBody>
@@ -5930,7 +5930,7 @@
               </a:defRPr>
             </a:pPr>
             <a:r>
-              <a:t>Total Parameters</a:t>
+              <a:t>Recall (t=0.05)</a:t>
             </a:r>
           </a:p>
         </p:txBody>
@@ -5977,12 +5977,12 @@
             <a:pPr algn="ctr">
               <a:defRPr sz="1000" b="1">
                 <a:solidFill>
-                  <a:srgbClr val="1E293B"/>
-                </a:solidFill>
-              </a:defRPr>
-            </a:pPr>
-            <a:r>
-              <a:t>217,475</a:t>
+                  <a:srgbClr val="059669"/>
+                </a:solidFill>
+              </a:defRPr>
+            </a:pPr>
+            <a:r>
+              <a:t>100%</a:t>
             </a:r>
           </a:p>
         </p:txBody>
@@ -6018,7 +6018,7 @@
               </a:defRPr>
             </a:pPr>
             <a:r>
-              <a:t>Train Samples</a:t>
+              <a:t>Total Parameters</a:t>
             </a:r>
           </a:p>
         </p:txBody>
@@ -6070,7 +6070,7 @@
               </a:defRPr>
             </a:pPr>
             <a:r>
-              <a:t>10,200</a:t>
+              <a:t>186,307</a:t>
             </a:r>
           </a:p>
         </p:txBody>
@@ -6106,7 +6106,7 @@
               </a:defRPr>
             </a:pPr>
             <a:r>
-              <a:t>Val Samples</a:t>
+              <a:t>Train Samples</a:t>
             </a:r>
           </a:p>
         </p:txBody>
@@ -6158,7 +6158,7 @@
               </a:defRPr>
             </a:pPr>
             <a:r>
-              <a:t>1,800</a:t>
+              <a:t>5,100</a:t>
             </a:r>
           </a:p>
         </p:txBody>
@@ -6194,7 +6194,7 @@
               </a:defRPr>
             </a:pPr>
             <a:r>
-              <a:t>Oversampling</a:t>
+              <a:t>Val Samples</a:t>
             </a:r>
           </a:p>
         </p:txBody>
@@ -6246,7 +6246,7 @@
               </a:defRPr>
             </a:pPr>
             <a:r>
-              <a:t>WeightedRandomSampler ✓</a:t>
+              <a:t>900</a:t>
             </a:r>
           </a:p>
         </p:txBody>
@@ -6282,7 +6282,7 @@
               </a:defRPr>
             </a:pPr>
             <a:r>
-              <a:t>Loss Weight (pos)</a:t>
+              <a:t>Balancing</a:t>
             </a:r>
           </a:p>
         </p:txBody>
@@ -6334,7 +6334,7 @@
               </a:defRPr>
             </a:pPr>
             <a:r>
-              <a:t>18.11</a:t>
+              <a:t>Sampler + pw=2.0</a:t>
             </a:r>
           </a:p>
         </p:txBody>
@@ -6482,7 +6482,7 @@
               </a:defRPr>
             </a:pPr>
             <a:r>
-              <a:t>RV College of Engineering® — BMS Institute of Technology</a:t>
+              <a:t>RV College of Engineering® — Bengaluru</a:t>
             </a:r>
           </a:p>
         </p:txBody>
@@ -6762,7 +6762,7 @@
         <p:spPr>
           <a:xfrm>
             <a:off x="274320" y="1645920"/>
-            <a:ext cx="11430000" cy="4572000"/>
+            <a:ext cx="10592642" cy="4572000"/>
           </a:xfrm>
           <a:prstGeom prst="rect">
             <a:avLst/>
@@ -6912,7 +6912,7 @@
               </a:defRPr>
             </a:pPr>
             <a:r>
-              <a:t>RV College of Engineering® — BMS Institute of Technology</a:t>
+              <a:t>RV College of Engineering® — Bengaluru</a:t>
             </a:r>
           </a:p>
         </p:txBody>
@@ -7293,7 +7293,7 @@
               </a:defRPr>
             </a:pPr>
             <a:r>
-              <a:t>• RGATv2 GNN with physics-informed loss and class-balanced training</a:t>
+              <a:t>• RGATv2 GNN: 93.4% accuracy, 9.5% precision, F1=0.151</a:t>
             </a:r>
           </a:p>
           <a:p>
@@ -7470,7 +7470,7 @@
         <p:spPr>
           <a:xfrm>
             <a:off x="6217920" y="1645920"/>
-            <a:ext cx="5486400" cy="4572000"/>
+            <a:ext cx="5486400" cy="2266904"/>
           </a:xfrm>
           <a:prstGeom prst="rect">
             <a:avLst/>
@@ -7620,7 +7620,7 @@
               </a:defRPr>
             </a:pPr>
             <a:r>
-              <a:t>RV College of Engineering® — BMS Institute of Technology</a:t>
+              <a:t>RV College of Engineering® — Bengaluru</a:t>
             </a:r>
           </a:p>
         </p:txBody>
@@ -8504,7 +8504,7 @@
               </a:defRPr>
             </a:pPr>
             <a:r>
-              <a:t>RV College of Engineering® — BMS Institute of Technology</a:t>
+              <a:t>RV College of Engineering® — Bengaluru</a:t>
             </a:r>
           </a:p>
         </p:txBody>
@@ -8886,60 +8886,30 @@
           </a:p>
         </p:txBody>
       </p:sp>
-      <p:sp>
-        <p:nvSpPr>
-          <p:cNvPr id="12" name="Rectangle 11"/>
-          <p:cNvSpPr/>
-          <p:nvPr/>
-        </p:nvSpPr>
+      <p:pic>
+        <p:nvPicPr>
+          <p:cNvPr id="12" name="Picture 11" descr="architecture.png"/>
+          <p:cNvPicPr>
+            <a:picLocks noChangeAspect="1"/>
+          </p:cNvPicPr>
+          <p:nvPr/>
+        </p:nvPicPr>
+        <p:blipFill>
+          <a:blip r:embed="rId2"/>
+          <a:stretch>
+            <a:fillRect/>
+          </a:stretch>
+        </p:blipFill>
         <p:spPr>
           <a:xfrm>
             <a:off x="6217920" y="1645920"/>
-            <a:ext cx="5303520" cy="4114800"/>
-          </a:xfrm>
-          <a:prstGeom prst="rect">
-            <a:avLst/>
-          </a:prstGeom>
-          <a:solidFill>
-            <a:srgbClr val="F1F5F9"/>
-          </a:solidFill>
-          <a:ln w="6350">
-            <a:solidFill>
-              <a:srgbClr val="003D7A"/>
-            </a:solidFill>
-          </a:ln>
-        </p:spPr>
-        <p:style>
-          <a:lnRef idx="1">
-            <a:schemeClr val="accent1"/>
-          </a:lnRef>
-          <a:fillRef idx="3">
-            <a:schemeClr val="accent1"/>
-          </a:fillRef>
-          <a:effectRef idx="2">
-            <a:schemeClr val="accent1"/>
-          </a:effectRef>
-          <a:fontRef idx="minor">
-            <a:schemeClr val="lt1"/>
-          </a:fontRef>
-        </p:style>
-        <p:txBody>
-          <a:bodyPr rtlCol="0" anchor="ctr"/>
-          <a:lstStyle/>
-          <a:p>
-            <a:pPr algn="ctr">
-              <a:defRPr sz="1100">
-                <a:solidFill>
-                  <a:srgbClr val="64748B"/>
-                </a:solidFill>
-              </a:defRPr>
-            </a:pPr>
-            <a:r>
-              <a:t>Architecture</a:t>
-            </a:r>
-          </a:p>
-        </p:txBody>
-      </p:sp>
+            <a:ext cx="5303520" cy="3851681"/>
+          </a:xfrm>
+          <a:prstGeom prst="rect">
+            <a:avLst/>
+          </a:prstGeom>
+        </p:spPr>
+      </p:pic>
     </p:spTree>
   </p:cSld>
   <p:clrMapOvr>
@@ -9083,7 +9053,7 @@
               </a:defRPr>
             </a:pPr>
             <a:r>
-              <a:t>RV College of Engineering® — BMS Institute of Technology</a:t>
+              <a:t>RV College of Engineering® — Bengaluru</a:t>
             </a:r>
           </a:p>
         </p:txBody>
@@ -9672,7 +9642,7 @@
               </a:defRPr>
             </a:pPr>
             <a:r>
-              <a:t>RV College of Engineering® — BMS Institute of Technology</a:t>
+              <a:t>RV College of Engineering® — Bengaluru</a:t>
             </a:r>
           </a:p>
         </p:txBody>
@@ -10625,60 +10595,30 @@
           </a:p>
         </p:txBody>
       </p:sp>
-      <p:sp>
-        <p:nvSpPr>
-          <p:cNvPr id="29" name="Rectangle 28"/>
-          <p:cNvSpPr/>
-          <p:nvPr/>
-        </p:nvSpPr>
+      <p:pic>
+        <p:nvPicPr>
+          <p:cNvPr id="29" name="Picture 28" descr="gnn_architecture.png"/>
+          <p:cNvPicPr>
+            <a:picLocks noChangeAspect="1"/>
+          </p:cNvPicPr>
+          <p:nvPr/>
+        </p:nvPicPr>
+        <p:blipFill>
+          <a:blip r:embed="rId2"/>
+          <a:stretch>
+            <a:fillRect/>
+          </a:stretch>
+        </p:blipFill>
         <p:spPr>
           <a:xfrm>
             <a:off x="6217920" y="1645920"/>
-            <a:ext cx="5303520" cy="4389120"/>
-          </a:xfrm>
-          <a:prstGeom prst="rect">
-            <a:avLst/>
-          </a:prstGeom>
-          <a:solidFill>
-            <a:srgbClr val="F1F5F9"/>
-          </a:solidFill>
-          <a:ln w="6350">
-            <a:solidFill>
-              <a:srgbClr val="003D7A"/>
-            </a:solidFill>
-          </a:ln>
-        </p:spPr>
-        <p:style>
-          <a:lnRef idx="1">
-            <a:schemeClr val="accent1"/>
-          </a:lnRef>
-          <a:fillRef idx="3">
-            <a:schemeClr val="accent1"/>
-          </a:fillRef>
-          <a:effectRef idx="2">
-            <a:schemeClr val="accent1"/>
-          </a:effectRef>
-          <a:fontRef idx="minor">
-            <a:schemeClr val="lt1"/>
-          </a:fontRef>
-        </p:style>
-        <p:txBody>
-          <a:bodyPr rtlCol="0" anchor="ctr"/>
-          <a:lstStyle/>
-          <a:p>
-            <a:pPr algn="ctr">
-              <a:defRPr sz="1100">
-                <a:solidFill>
-                  <a:srgbClr val="64748B"/>
-                </a:solidFill>
-              </a:defRPr>
-            </a:pPr>
-            <a:r>
-              <a:t>Gnn Architecture</a:t>
-            </a:r>
-          </a:p>
-        </p:txBody>
-      </p:sp>
+            <a:ext cx="5303520" cy="1233068"/>
+          </a:xfrm>
+          <a:prstGeom prst="rect">
+            <a:avLst/>
+          </a:prstGeom>
+        </p:spPr>
+      </p:pic>
     </p:spTree>
   </p:cSld>
   <p:clrMapOvr>
@@ -10822,7 +10762,7 @@
               </a:defRPr>
             </a:pPr>
             <a:r>
-              <a:t>RV College of Engineering® — BMS Institute of Technology</a:t>
+              <a:t>RV College of Engineering® — Bengaluru</a:t>
             </a:r>
           </a:p>
         </p:txBody>
@@ -11772,7 +11712,7 @@
               </a:defRPr>
             </a:pPr>
             <a:r>
-              <a:t>RV College of Engineering® — BMS Institute of Technology</a:t>
+              <a:t>RV College of Engineering® — Bengaluru</a:t>
             </a:r>
           </a:p>
         </p:txBody>
@@ -12503,60 +12443,30 @@
           </a:p>
         </p:txBody>
       </p:sp>
-      <p:sp>
-        <p:nvSpPr>
-          <p:cNvPr id="24" name="Rectangle 23"/>
-          <p:cNvSpPr/>
-          <p:nvPr/>
-        </p:nvSpPr>
+      <p:pic>
+        <p:nvPicPr>
+          <p:cNvPr id="24" name="Picture 23" descr="pipeline.png"/>
+          <p:cNvPicPr>
+            <a:picLocks noChangeAspect="1"/>
+          </p:cNvPicPr>
+          <p:nvPr/>
+        </p:nvPicPr>
+        <p:blipFill>
+          <a:blip r:embed="rId2"/>
+          <a:stretch>
+            <a:fillRect/>
+          </a:stretch>
+        </p:blipFill>
         <p:spPr>
           <a:xfrm>
             <a:off x="5943600" y="1645920"/>
-            <a:ext cx="5669280" cy="4114800"/>
-          </a:xfrm>
-          <a:prstGeom prst="rect">
-            <a:avLst/>
-          </a:prstGeom>
-          <a:solidFill>
-            <a:srgbClr val="F1F5F9"/>
-          </a:solidFill>
-          <a:ln w="6350">
-            <a:solidFill>
-              <a:srgbClr val="003D7A"/>
-            </a:solidFill>
-          </a:ln>
-        </p:spPr>
-        <p:style>
-          <a:lnRef idx="1">
-            <a:schemeClr val="accent1"/>
-          </a:lnRef>
-          <a:fillRef idx="3">
-            <a:schemeClr val="accent1"/>
-          </a:fillRef>
-          <a:effectRef idx="2">
-            <a:schemeClr val="accent1"/>
-          </a:effectRef>
-          <a:fontRef idx="minor">
-            <a:schemeClr val="lt1"/>
-          </a:fontRef>
-        </p:style>
-        <p:txBody>
-          <a:bodyPr rtlCol="0" anchor="ctr"/>
-          <a:lstStyle/>
-          <a:p>
-            <a:pPr algn="ctr">
-              <a:defRPr sz="1100">
-                <a:solidFill>
-                  <a:srgbClr val="64748B"/>
-                </a:solidFill>
-              </a:defRPr>
-            </a:pPr>
-            <a:r>
-              <a:t>Pipeline</a:t>
-            </a:r>
-          </a:p>
-        </p:txBody>
-      </p:sp>
+            <a:ext cx="5669280" cy="853935"/>
+          </a:xfrm>
+          <a:prstGeom prst="rect">
+            <a:avLst/>
+          </a:prstGeom>
+        </p:spPr>
+      </p:pic>
     </p:spTree>
   </p:cSld>
   <p:clrMapOvr>
@@ -12700,7 +12610,7 @@
               </a:defRPr>
             </a:pPr>
             <a:r>
-              <a:t>RV College of Engineering® — BMS Institute of Technology</a:t>
+              <a:t>RV College of Engineering® — Bengaluru</a:t>
             </a:r>
           </a:p>
         </p:txBody>
@@ -13182,60 +13092,30 @@
           </a:p>
         </p:txBody>
       </p:sp>
-      <p:sp>
-        <p:nvSpPr>
-          <p:cNvPr id="13" name="Rectangle 12"/>
-          <p:cNvSpPr/>
-          <p:nvPr/>
-        </p:nvSpPr>
+      <p:pic>
+        <p:nvPicPr>
+          <p:cNvPr id="13" name="Picture 12" descr="gnn_architecture.png"/>
+          <p:cNvPicPr>
+            <a:picLocks noChangeAspect="1"/>
+          </p:cNvPicPr>
+          <p:nvPr/>
+        </p:nvPicPr>
+        <p:blipFill>
+          <a:blip r:embed="rId2"/>
+          <a:stretch>
+            <a:fillRect/>
+          </a:stretch>
+        </p:blipFill>
         <p:spPr>
           <a:xfrm>
             <a:off x="5760720" y="1645920"/>
-            <a:ext cx="5943600" cy="4572000"/>
-          </a:xfrm>
-          <a:prstGeom prst="rect">
-            <a:avLst/>
-          </a:prstGeom>
-          <a:solidFill>
-            <a:srgbClr val="F1F5F9"/>
-          </a:solidFill>
-          <a:ln w="6350">
-            <a:solidFill>
-              <a:srgbClr val="003D7A"/>
-            </a:solidFill>
-          </a:ln>
-        </p:spPr>
-        <p:style>
-          <a:lnRef idx="1">
-            <a:schemeClr val="accent1"/>
-          </a:lnRef>
-          <a:fillRef idx="3">
-            <a:schemeClr val="accent1"/>
-          </a:fillRef>
-          <a:effectRef idx="2">
-            <a:schemeClr val="accent1"/>
-          </a:effectRef>
-          <a:fontRef idx="minor">
-            <a:schemeClr val="lt1"/>
-          </a:fontRef>
-        </p:style>
-        <p:txBody>
-          <a:bodyPr rtlCol="0" anchor="ctr"/>
-          <a:lstStyle/>
-          <a:p>
-            <a:pPr algn="ctr">
-              <a:defRPr sz="1100">
-                <a:solidFill>
-                  <a:srgbClr val="64748B"/>
-                </a:solidFill>
-              </a:defRPr>
-            </a:pPr>
-            <a:r>
-              <a:t>Gnn Architecture</a:t>
-            </a:r>
-          </a:p>
-        </p:txBody>
-      </p:sp>
+            <a:ext cx="5943600" cy="1381887"/>
+          </a:xfrm>
+          <a:prstGeom prst="rect">
+            <a:avLst/>
+          </a:prstGeom>
+        </p:spPr>
+      </p:pic>
     </p:spTree>
   </p:cSld>
   <p:clrMapOvr>
@@ -13379,7 +13259,7 @@
               </a:defRPr>
             </a:pPr>
             <a:r>
-              <a:t>RV College of Engineering® — BMS Institute of Technology</a:t>
+              <a:t>RV College of Engineering® — Bengaluru</a:t>
             </a:r>
           </a:p>
         </p:txBody>

</xml_diff>

<commit_message>
feat(docs): detailed GNN architecture diagram and presentation script
- Replaced gnn_architecture.png with detailed Graphviz diagram showing
  full RGATv2 pipeline: encoders, 3x GATv2Conv layers, output heads,
  FaultClassifier, and PhysicsInformedLoss
- Added docs/presentation_script.md — 15-slide script with Q&A prep
- Regenerated PPT with updated diagram
</commit_message>
<xml_diff>
--- a/docs/Metro_Grid_Digital_Twin.pptx
+++ b/docs/Metro_Grid_Digital_Twin.pptx
@@ -10612,7 +10612,7 @@
         <p:spPr>
           <a:xfrm>
             <a:off x="6217920" y="1645920"/>
-            <a:ext cx="5303520" cy="1233068"/>
+            <a:ext cx="4481871" cy="4389120"/>
           </a:xfrm>
           <a:prstGeom prst="rect">
             <a:avLst/>
@@ -13109,7 +13109,7 @@
         <p:spPr>
           <a:xfrm>
             <a:off x="5760720" y="1645920"/>
-            <a:ext cx="5943600" cy="1381887"/>
+            <a:ext cx="4668615" cy="4572000"/>
           </a:xfrm>
           <a:prstGeom prst="rect">
             <a:avLst/>

</xml_diff>